<commit_message>
feat: add Clerk Assistant to triage student queries to Faculty or Admin and resolve request not found error
</commit_message>
<xml_diff>
--- a/Student_HelpDesk_AI_Project_Presentation_Updated.pptx
+++ b/Student_HelpDesk_AI_Project_Presentation_Updated.pptx
@@ -6,6 +6,7 @@
   </p:sldMasterIdLst>
   <p:sldIdLst>
     <p:sldId id="256" r:id="rId7"/>
+    <p:sldId id="271" r:id="rId22"/>
     <p:sldId id="257" r:id="rId8"/>
     <p:sldId id="258" r:id="rId9"/>
     <p:sldId id="259" r:id="rId10"/>
@@ -7355,6 +7356,698 @@
             <a:br/>
             <a:r>
               <a:t>Questions &amp; Discussion are welcome.</a:t>
+            </a:r>
+          </a:p>
+        </p:txBody>
+      </p:sp>
+    </p:spTree>
+  </p:cSld>
+  <p:clrMapOvr>
+    <a:masterClrMapping/>
+  </p:clrMapOvr>
+</p:sld>
+</file>
+
+<file path=ppt/slides/slide16.xml><?xml version="1.0" encoding="utf-8"?>
+<p:sld xmlns:a="http://schemas.openxmlformats.org/drawingml/2006/main" xmlns:p="http://schemas.openxmlformats.org/presentationml/2006/main" xmlns:r="http://schemas.openxmlformats.org/officeDocument/2006/relationships">
+  <p:cSld>
+    <p:spTree>
+      <p:nvGrpSpPr>
+        <p:cNvPr id="1" name=""/>
+        <p:cNvGrpSpPr/>
+        <p:nvPr/>
+      </p:nvGrpSpPr>
+      <p:grpSpPr/>
+      <p:sp>
+        <p:nvSpPr>
+          <p:cNvPr id="2" name="Rectangle 1"/>
+          <p:cNvSpPr/>
+          <p:nvPr/>
+        </p:nvSpPr>
+        <p:spPr>
+          <a:xfrm>
+            <a:off x="0" y="0"/>
+            <a:ext cx="12191695" cy="6858000"/>
+          </a:xfrm>
+          <a:prstGeom prst="rect">
+            <a:avLst/>
+          </a:prstGeom>
+          <a:solidFill>
+            <a:srgbClr val="F8FAFC"/>
+          </a:solidFill>
+          <a:ln>
+            <a:noFill/>
+          </a:ln>
+        </p:spPr>
+        <p:style>
+          <a:lnRef idx="1">
+            <a:schemeClr val="accent1"/>
+          </a:lnRef>
+          <a:fillRef idx="3">
+            <a:schemeClr val="accent1"/>
+          </a:fillRef>
+          <a:effectRef idx="2">
+            <a:schemeClr val="accent1"/>
+          </a:effectRef>
+          <a:fontRef idx="minor">
+            <a:schemeClr val="lt1"/>
+          </a:fontRef>
+        </p:style>
+        <p:txBody>
+          <a:bodyPr rtlCol="0" anchor="ctr"/>
+          <a:lstStyle/>
+          <a:p>
+            <a:pPr algn="ctr"/>
+          </a:p>
+        </p:txBody>
+      </p:sp>
+      <p:sp>
+        <p:nvSpPr>
+          <p:cNvPr id="3" name="Rectangle 2"/>
+          <p:cNvSpPr/>
+          <p:nvPr/>
+        </p:nvSpPr>
+        <p:spPr>
+          <a:xfrm>
+            <a:off x="731520" y="365760"/>
+            <a:ext cx="10698480" cy="36576"/>
+          </a:xfrm>
+          <a:prstGeom prst="rect">
+            <a:avLst/>
+          </a:prstGeom>
+          <a:solidFill>
+            <a:srgbClr val="1E3A8A"/>
+          </a:solidFill>
+          <a:ln>
+            <a:noFill/>
+          </a:ln>
+        </p:spPr>
+        <p:style>
+          <a:lnRef idx="1">
+            <a:schemeClr val="accent1"/>
+          </a:lnRef>
+          <a:fillRef idx="3">
+            <a:schemeClr val="accent1"/>
+          </a:fillRef>
+          <a:effectRef idx="2">
+            <a:schemeClr val="accent1"/>
+          </a:effectRef>
+          <a:fontRef idx="minor">
+            <a:schemeClr val="lt1"/>
+          </a:fontRef>
+        </p:style>
+        <p:txBody>
+          <a:bodyPr rtlCol="0" anchor="ctr"/>
+          <a:lstStyle/>
+          <a:p>
+            <a:pPr algn="ctr"/>
+          </a:p>
+        </p:txBody>
+      </p:sp>
+      <p:sp>
+        <p:nvSpPr>
+          <p:cNvPr id="4" name="TextBox 3"/>
+          <p:cNvSpPr txBox="1"/>
+          <p:nvPr/>
+        </p:nvSpPr>
+        <p:spPr>
+          <a:xfrm>
+            <a:off x="731520" y="438912"/>
+            <a:ext cx="9144000" cy="274320"/>
+          </a:xfrm>
+          <a:prstGeom prst="rect">
+            <a:avLst/>
+          </a:prstGeom>
+          <a:noFill/>
+        </p:spPr>
+        <p:txBody>
+          <a:bodyPr wrap="square" lIns="0" tIns="0" rIns="0" bIns="0">
+            <a:spAutoFit/>
+          </a:bodyPr>
+          <a:lstStyle/>
+          <a:p>
+            <a:pPr>
+              <a:defRPr sz="1100" b="1">
+                <a:solidFill>
+                  <a:srgbClr val="1E3A8A"/>
+                </a:solidFill>
+              </a:defRPr>
+            </a:pPr>
+            <a:r>
+              <a:t>PROJECT ACCESS &amp; DEPLOYMENT</a:t>
+            </a:r>
+          </a:p>
+        </p:txBody>
+      </p:sp>
+      <p:sp>
+        <p:nvSpPr>
+          <p:cNvPr id="5" name="TextBox 4"/>
+          <p:cNvSpPr txBox="1"/>
+          <p:nvPr/>
+        </p:nvSpPr>
+        <p:spPr>
+          <a:xfrm>
+            <a:off x="731520" y="713232"/>
+            <a:ext cx="10698480" cy="502920"/>
+          </a:xfrm>
+          <a:prstGeom prst="rect">
+            <a:avLst/>
+          </a:prstGeom>
+          <a:noFill/>
+        </p:spPr>
+        <p:txBody>
+          <a:bodyPr wrap="square" lIns="0" tIns="0" rIns="0" bIns="0">
+            <a:spAutoFit/>
+          </a:bodyPr>
+          <a:lstStyle/>
+          <a:p>
+            <a:pPr>
+              <a:defRPr sz="2200" b="1">
+                <a:solidFill>
+                  <a:srgbClr val="0F172A"/>
+                </a:solidFill>
+              </a:defRPr>
+            </a:pPr>
+            <a:r>
+              <a:t>Repository &amp; Live Deployment Links</a:t>
+            </a:r>
+          </a:p>
+        </p:txBody>
+      </p:sp>
+      <p:sp>
+        <p:nvSpPr>
+          <p:cNvPr id="6" name="Rounded Rectangle 5"/>
+          <p:cNvSpPr/>
+          <p:nvPr/>
+        </p:nvSpPr>
+        <p:spPr>
+          <a:xfrm>
+            <a:off x="731520" y="1417320"/>
+            <a:ext cx="5120640" cy="4663440"/>
+          </a:xfrm>
+          <a:prstGeom prst="roundRect">
+            <a:avLst/>
+          </a:prstGeom>
+          <a:solidFill>
+            <a:srgbClr val="FFFFFF"/>
+          </a:solidFill>
+          <a:ln w="12700">
+            <a:solidFill>
+              <a:srgbClr val="CBD5E1"/>
+            </a:solidFill>
+          </a:ln>
+        </p:spPr>
+        <p:style>
+          <a:lnRef idx="1">
+            <a:schemeClr val="accent1"/>
+          </a:lnRef>
+          <a:fillRef idx="3">
+            <a:schemeClr val="accent1"/>
+          </a:fillRef>
+          <a:effectRef idx="2">
+            <a:schemeClr val="accent1"/>
+          </a:effectRef>
+          <a:fontRef idx="minor">
+            <a:schemeClr val="lt1"/>
+          </a:fontRef>
+        </p:style>
+        <p:txBody>
+          <a:bodyPr rtlCol="0" anchor="ctr"/>
+          <a:lstStyle/>
+          <a:p>
+            <a:pPr algn="ctr"/>
+          </a:p>
+        </p:txBody>
+      </p:sp>
+      <p:sp>
+        <p:nvSpPr>
+          <p:cNvPr id="7" name="TextBox 6"/>
+          <p:cNvSpPr txBox="1"/>
+          <p:nvPr/>
+        </p:nvSpPr>
+        <p:spPr>
+          <a:xfrm>
+            <a:off x="960120" y="1645920"/>
+            <a:ext cx="4663440" cy="4206240"/>
+          </a:xfrm>
+          <a:prstGeom prst="rect">
+            <a:avLst/>
+          </a:prstGeom>
+          <a:noFill/>
+        </p:spPr>
+        <p:txBody>
+          <a:bodyPr wrap="square">
+            <a:spAutoFit/>
+          </a:bodyPr>
+          <a:lstStyle/>
+          <a:p>
+            <a:pPr>
+              <a:defRPr sz="1800" b="1">
+                <a:solidFill>
+                  <a:srgbClr val="0F172A"/>
+                </a:solidFill>
+              </a:defRPr>
+            </a:pPr>
+            <a:r>
+              <a:t>GitHub Source Code</a:t>
+            </a:r>
+          </a:p>
+          <a:p>
+            <a:pPr>
+              <a:spcBef>
+                <a:spcPts val="800"/>
+              </a:spcBef>
+            </a:pPr>
+            <a:r>
+              <a:rPr sz="1100" b="1">
+                <a:solidFill>
+                  <a:srgbClr val="475569"/>
+                </a:solidFill>
+              </a:rPr>
+              <a:t>Repository URL:
+</a:t>
+            </a:r>
+            <a:r>
+              <a:rPr sz="1200" b="1" u="sng">
+                <a:solidFill>
+                  <a:srgbClr val="2563EB"/>
+                </a:solidFill>
+                <a:hlinkClick r:id="rId2"/>
+              </a:rPr>
+              <a:t>https://github.com/MeetKadiya/StudentHelpdesk</a:t>
+            </a:r>
+          </a:p>
+          <a:p>
+            <a:pPr>
+              <a:spcBef>
+                <a:spcPts val="1400"/>
+              </a:spcBef>
+            </a:pPr>
+            <a:r>
+              <a:rPr sz="1200" b="1">
+                <a:solidFill>
+                  <a:srgbClr val="1E293B"/>
+                </a:solidFill>
+              </a:rPr>
+              <a:t>Key Highlights:
+</a:t>
+            </a:r>
+          </a:p>
+          <a:p>
+            <a:pPr>
+              <a:spcBef>
+                <a:spcPts val="400"/>
+              </a:spcBef>
+            </a:pPr>
+            <a:r>
+              <a:rPr b="1">
+                <a:solidFill>
+                  <a:srgbClr val="2563EB"/>
+                </a:solidFill>
+              </a:rPr>
+              <a:t>•  </a:t>
+            </a:r>
+            <a:r>
+              <a:rPr sz="1100">
+                <a:solidFill>
+                  <a:srgbClr val="334155"/>
+                </a:solidFill>
+              </a:rPr>
+              <a:t>Complete Full-Stack &amp; AI Agent Codebase</a:t>
+            </a:r>
+          </a:p>
+          <a:p>
+            <a:pPr>
+              <a:spcBef>
+                <a:spcPts val="400"/>
+              </a:spcBef>
+            </a:pPr>
+            <a:r>
+              <a:rPr b="1">
+                <a:solidFill>
+                  <a:srgbClr val="2563EB"/>
+                </a:solidFill>
+              </a:rPr>
+              <a:t>•  </a:t>
+            </a:r>
+            <a:r>
+              <a:rPr sz="1100">
+                <a:solidFill>
+                  <a:srgbClr val="334155"/>
+                </a:solidFill>
+              </a:rPr>
+              <a:t>Next.js 15 App Router with Tailwind CSS &amp; RBAC</a:t>
+            </a:r>
+          </a:p>
+          <a:p>
+            <a:pPr>
+              <a:spcBef>
+                <a:spcPts val="400"/>
+              </a:spcBef>
+            </a:pPr>
+            <a:r>
+              <a:rPr b="1">
+                <a:solidFill>
+                  <a:srgbClr val="2563EB"/>
+                </a:solidFill>
+              </a:rPr>
+              <a:t>•  </a:t>
+            </a:r>
+            <a:r>
+              <a:rPr sz="1100">
+                <a:solidFill>
+                  <a:srgbClr val="334155"/>
+                </a:solidFill>
+              </a:rPr>
+              <a:t>FastAPI Backend with Async SQLAlchemy &amp; Alembic</a:t>
+            </a:r>
+          </a:p>
+          <a:p>
+            <a:pPr>
+              <a:spcBef>
+                <a:spcPts val="400"/>
+              </a:spcBef>
+            </a:pPr>
+            <a:r>
+              <a:rPr b="1">
+                <a:solidFill>
+                  <a:srgbClr val="2563EB"/>
+                </a:solidFill>
+              </a:rPr>
+              <a:t>•  </a:t>
+            </a:r>
+            <a:r>
+              <a:rPr sz="1100">
+                <a:solidFill>
+                  <a:srgbClr val="334155"/>
+                </a:solidFill>
+              </a:rPr>
+              <a:t>LangGraph Multi-Agent RAG Pipeline with FAISS</a:t>
+            </a:r>
+          </a:p>
+          <a:p>
+            <a:pPr>
+              <a:spcBef>
+                <a:spcPts val="400"/>
+              </a:spcBef>
+            </a:pPr>
+            <a:r>
+              <a:rPr b="1">
+                <a:solidFill>
+                  <a:srgbClr val="2563EB"/>
+                </a:solidFill>
+              </a:rPr>
+              <a:t>•  </a:t>
+            </a:r>
+            <a:r>
+              <a:rPr sz="1100">
+                <a:solidFill>
+                  <a:srgbClr val="334155"/>
+                </a:solidFill>
+              </a:rPr>
+              <a:t>Docker &amp; Docker Compose Dev &amp; Production Configs</a:t>
+            </a:r>
+          </a:p>
+          <a:p>
+            <a:pPr>
+              <a:spcBef>
+                <a:spcPts val="400"/>
+              </a:spcBef>
+            </a:pPr>
+            <a:r>
+              <a:rPr b="1">
+                <a:solidFill>
+                  <a:srgbClr val="2563EB"/>
+                </a:solidFill>
+              </a:rPr>
+              <a:t>•  </a:t>
+            </a:r>
+            <a:r>
+              <a:rPr sz="1100">
+                <a:solidFill>
+                  <a:srgbClr val="334155"/>
+                </a:solidFill>
+              </a:rPr>
+              <a:t>Comprehensive Test Suites &amp; Documentation</a:t>
+            </a:r>
+          </a:p>
+        </p:txBody>
+      </p:sp>
+      <p:sp>
+        <p:nvSpPr>
+          <p:cNvPr id="8" name="Rounded Rectangle 7"/>
+          <p:cNvSpPr/>
+          <p:nvPr/>
+        </p:nvSpPr>
+        <p:spPr>
+          <a:xfrm>
+            <a:off x="6217920" y="1417320"/>
+            <a:ext cx="5212080" cy="4663440"/>
+          </a:xfrm>
+          <a:prstGeom prst="roundRect">
+            <a:avLst/>
+          </a:prstGeom>
+          <a:solidFill>
+            <a:srgbClr val="FFFFFF"/>
+          </a:solidFill>
+          <a:ln w="19050">
+            <a:solidFill>
+              <a:srgbClr val="93C5FD"/>
+            </a:solidFill>
+          </a:ln>
+        </p:spPr>
+        <p:style>
+          <a:lnRef idx="1">
+            <a:schemeClr val="accent1"/>
+          </a:lnRef>
+          <a:fillRef idx="3">
+            <a:schemeClr val="accent1"/>
+          </a:fillRef>
+          <a:effectRef idx="2">
+            <a:schemeClr val="accent1"/>
+          </a:effectRef>
+          <a:fontRef idx="minor">
+            <a:schemeClr val="lt1"/>
+          </a:fontRef>
+        </p:style>
+        <p:txBody>
+          <a:bodyPr rtlCol="0" anchor="ctr"/>
+          <a:lstStyle/>
+          <a:p>
+            <a:pPr algn="ctr"/>
+          </a:p>
+        </p:txBody>
+      </p:sp>
+      <p:sp>
+        <p:nvSpPr>
+          <p:cNvPr id="9" name="TextBox 8"/>
+          <p:cNvSpPr txBox="1"/>
+          <p:nvPr/>
+        </p:nvSpPr>
+        <p:spPr>
+          <a:xfrm>
+            <a:off x="6446520" y="1645920"/>
+            <a:ext cx="4754880" cy="4206240"/>
+          </a:xfrm>
+          <a:prstGeom prst="rect">
+            <a:avLst/>
+          </a:prstGeom>
+          <a:noFill/>
+        </p:spPr>
+        <p:txBody>
+          <a:bodyPr wrap="square">
+            <a:spAutoFit/>
+          </a:bodyPr>
+          <a:lstStyle/>
+          <a:p>
+            <a:pPr>
+              <a:defRPr sz="1800" b="1">
+                <a:solidFill>
+                  <a:srgbClr val="1E3A8A"/>
+                </a:solidFill>
+              </a:defRPr>
+            </a:pPr>
+            <a:r>
+              <a:t>Live Cloud Deployment</a:t>
+            </a:r>
+          </a:p>
+          <a:p>
+            <a:pPr>
+              <a:spcBef>
+                <a:spcPts val="800"/>
+              </a:spcBef>
+            </a:pPr>
+            <a:r>
+              <a:rPr sz="1100" b="1">
+                <a:solidFill>
+                  <a:srgbClr val="475569"/>
+                </a:solidFill>
+              </a:rPr>
+              <a:t>Application URL:
+</a:t>
+            </a:r>
+            <a:r>
+              <a:rPr sz="1200" b="1" u="sng">
+                <a:solidFill>
+                  <a:srgbClr val="2563EB"/>
+                </a:solidFill>
+                <a:hlinkClick r:id="rId3"/>
+              </a:rPr>
+              <a:t>https://student-help-desk-sou.vercel.app/</a:t>
+            </a:r>
+          </a:p>
+          <a:p>
+            <a:pPr>
+              <a:spcBef>
+                <a:spcPts val="1400"/>
+              </a:spcBef>
+            </a:pPr>
+            <a:r>
+              <a:rPr sz="1200" b="1">
+                <a:solidFill>
+                  <a:srgbClr val="1E293B"/>
+                </a:solidFill>
+              </a:rPr>
+              <a:t>Cloud Architecture &amp; Live Portals:
+</a:t>
+            </a:r>
+          </a:p>
+          <a:p>
+            <a:pPr>
+              <a:spcBef>
+                <a:spcPts val="400"/>
+              </a:spcBef>
+            </a:pPr>
+            <a:r>
+              <a:rPr b="1">
+                <a:solidFill>
+                  <a:srgbClr val="16A34A"/>
+                </a:solidFill>
+              </a:rPr>
+              <a:t>✓  </a:t>
+            </a:r>
+            <a:r>
+              <a:rPr sz="1100">
+                <a:solidFill>
+                  <a:srgbClr val="334155"/>
+                </a:solidFill>
+              </a:rPr>
+              <a:t>Frontend: Deployed on Vercel Edge Platform</a:t>
+            </a:r>
+          </a:p>
+          <a:p>
+            <a:pPr>
+              <a:spcBef>
+                <a:spcPts val="400"/>
+              </a:spcBef>
+            </a:pPr>
+            <a:r>
+              <a:rPr b="1">
+                <a:solidFill>
+                  <a:srgbClr val="16A34A"/>
+                </a:solidFill>
+              </a:rPr>
+              <a:t>✓  </a:t>
+            </a:r>
+            <a:r>
+              <a:rPr sz="1100">
+                <a:solidFill>
+                  <a:srgbClr val="334155"/>
+                </a:solidFill>
+              </a:rPr>
+              <a:t>Backend API: Containerized FastAPI on Render</a:t>
+            </a:r>
+          </a:p>
+          <a:p>
+            <a:pPr>
+              <a:spcBef>
+                <a:spcPts val="400"/>
+              </a:spcBef>
+            </a:pPr>
+            <a:r>
+              <a:rPr b="1">
+                <a:solidFill>
+                  <a:srgbClr val="16A34A"/>
+                </a:solidFill>
+              </a:rPr>
+              <a:t>✓  </a:t>
+            </a:r>
+            <a:r>
+              <a:rPr sz="1100">
+                <a:solidFill>
+                  <a:srgbClr val="334155"/>
+                </a:solidFill>
+              </a:rPr>
+              <a:t>Database: Managed PostgreSQL &amp; pgvector on Supabase</a:t>
+            </a:r>
+          </a:p>
+          <a:p>
+            <a:pPr>
+              <a:spcBef>
+                <a:spcPts val="400"/>
+              </a:spcBef>
+            </a:pPr>
+            <a:r>
+              <a:rPr b="1">
+                <a:solidFill>
+                  <a:srgbClr val="16A34A"/>
+                </a:solidFill>
+              </a:rPr>
+              <a:t>✓  </a:t>
+            </a:r>
+            <a:r>
+              <a:rPr sz="1100">
+                <a:solidFill>
+                  <a:srgbClr val="334155"/>
+                </a:solidFill>
+              </a:rPr>
+              <a:t>Student Portal: Ticket Submission &amp; 24/7 AI Assistance</a:t>
+            </a:r>
+          </a:p>
+          <a:p>
+            <a:pPr>
+              <a:spcBef>
+                <a:spcPts val="400"/>
+              </a:spcBef>
+            </a:pPr>
+            <a:r>
+              <a:rPr b="1">
+                <a:solidFill>
+                  <a:srgbClr val="16A34A"/>
+                </a:solidFill>
+              </a:rPr>
+              <a:t>✓  </a:t>
+            </a:r>
+            <a:r>
+              <a:rPr sz="1100">
+                <a:solidFill>
+                  <a:srgbClr val="334155"/>
+                </a:solidFill>
+              </a:rPr>
+              <a:t>Faculty Portal: Grievance Escalation &amp; Answer Verification</a:t>
+            </a:r>
+          </a:p>
+          <a:p>
+            <a:pPr>
+              <a:spcBef>
+                <a:spcPts val="400"/>
+              </a:spcBef>
+            </a:pPr>
+            <a:r>
+              <a:rPr b="1">
+                <a:solidFill>
+                  <a:srgbClr val="16A34A"/>
+                </a:solidFill>
+              </a:rPr>
+              <a:t>✓  </a:t>
+            </a:r>
+            <a:r>
+              <a:rPr sz="1100">
+                <a:solidFill>
+                  <a:srgbClr val="334155"/>
+                </a:solidFill>
+              </a:rPr>
+              <a:t>Admin Portal: System Analytics, RBAC &amp; Routing Rules</a:t>
             </a:r>
           </a:p>
         </p:txBody>

</xml_diff>